<commit_message>
Shift demo to hosted backend deployment
This change repositions the project around a Vercel frontend plus a separate FastAPI backend, with Gonka as the recommended live demo provider and backend-only secrets. It updates environment templates, deployment/runbook documentation, architecture and provider strategy docs, release notes, and submission materials to reflect the hosted-demo path while preserving the deterministic offline fallback. It also adds phase summary docs and clarifies the final checklist and frontend/backend configuration split.
</commit_message>
<xml_diff>
--- a/submission/02_pitch/TRUST_INTERCEPT_Pitch_Deck.pptx
+++ b/submission/02_pitch/TRUST_INTERCEPT_Pitch_Deck.pptx
@@ -17,6 +17,7 @@
     <p:sldId id="265" r:id="rId16"/>
     <p:sldId id="266" r:id="rId17"/>
     <p:sldId id="267" r:id="rId18"/>
+    <p:sldId id="268" r:id="rId19"/>
   </p:sldIdLst>
   <p:sldSz cx="12191695" cy="6858000" type="screen4x3"/>
   <p:notesSz cx="6858000" cy="9144000"/>
@@ -3153,10 +3154,7 @@
           <a:lstStyle/>
           <a:p>
             <a:pPr>
-              <a:spcAft>
-                <a:spcPts val="800"/>
-              </a:spcAft>
-              <a:defRPr sz="2200"/>
+              <a:defRPr sz="2500"/>
             </a:pPr>
             <a:r>
               <a:t>Aegis Signal Lab</a:t>
@@ -3240,9 +3238,6 @@
           <a:lstStyle/>
           <a:p>
             <a:pPr>
-              <a:spcAft>
-                <a:spcPts val="800"/>
-              </a:spcAft>
               <a:defRPr sz="2200"/>
             </a:pPr>
             <a:r>
@@ -3258,7 +3253,7 @@
             </a:r>
             <a:br/>
             <a:r>
-              <a:t>Offline deterministic safety floor.</a:t>
+              <a:t>Offline deterministic recovery path.</a:t>
             </a:r>
           </a:p>
         </p:txBody>
@@ -3307,7 +3302,7 @@
               <a:defRPr sz="2800" b="1"/>
             </a:pPr>
             <a:r>
-              <a:t>3-Minute Demo</a:t>
+              <a:t>Live Demo Architecture</a:t>
             </a:r>
           </a:p>
         </p:txBody>
@@ -3335,13 +3330,14 @@
           <a:lstStyle/>
           <a:p>
             <a:pPr>
-              <a:spcAft>
-                <a:spcPts val="800"/>
-              </a:spcAft>
               <a:defRPr sz="2200"/>
             </a:pPr>
             <a:r>
-              <a:t>Parcel scam → investigation → adversarial challenge → independent verification → human approval → replay → immunity.</a:t>
+              <a:t>Vercel frontend → HTTPS → FastAPI backend → hosted LLM provider.</a:t>
+            </a:r>
+            <a:br/>
+            <a:r>
+              <a:t>API keys remain server-side. Offline mode is emergency recovery, not the primary demo.</a:t>
             </a:r>
           </a:p>
         </p:txBody>
@@ -3390,7 +3386,7 @@
               <a:defRPr sz="2800" b="1"/>
             </a:pPr>
             <a:r>
-              <a:t>Closing</a:t>
+              <a:t>3-Minute Demo</a:t>
             </a:r>
           </a:p>
         </p:txBody>
@@ -3418,10 +3414,87 @@
           <a:lstStyle/>
           <a:p>
             <a:pPr>
-              <a:spcAft>
-                <a:spcPts val="800"/>
-              </a:spcAft>
               <a:defRPr sz="2200"/>
+            </a:pPr>
+            <a:r>
+              <a:t>Parcel scam → investigation → adversarial challenge → independent verification → human approval → replay → immunity.</a:t>
+            </a:r>
+          </a:p>
+        </p:txBody>
+      </p:sp>
+    </p:spTree>
+  </p:cSld>
+  <p:clrMapOvr>
+    <a:masterClrMapping/>
+  </p:clrMapOvr>
+</p:sld>
+</file>
+
+<file path=ppt/slides/slide13.xml><?xml version="1.0" encoding="utf-8"?>
+<p:sld xmlns:a="http://schemas.openxmlformats.org/drawingml/2006/main" xmlns:p="http://schemas.openxmlformats.org/presentationml/2006/main" xmlns:r="http://schemas.openxmlformats.org/officeDocument/2006/relationships">
+  <p:cSld>
+    <p:spTree>
+      <p:nvGrpSpPr>
+        <p:cNvPr id="1" name=""/>
+        <p:cNvGrpSpPr/>
+        <p:nvPr/>
+      </p:nvGrpSpPr>
+      <p:grpSpPr/>
+      <p:sp>
+        <p:nvSpPr>
+          <p:cNvPr id="2" name="TextBox 1"/>
+          <p:cNvSpPr txBox="1"/>
+          <p:nvPr/>
+        </p:nvSpPr>
+        <p:spPr>
+          <a:xfrm>
+            <a:off x="640080" y="502920"/>
+            <a:ext cx="10972800" cy="914400"/>
+          </a:xfrm>
+          <a:prstGeom prst="rect">
+            <a:avLst/>
+          </a:prstGeom>
+          <a:noFill/>
+        </p:spPr>
+        <p:txBody>
+          <a:bodyPr wrap="none">
+            <a:spAutoFit/>
+          </a:bodyPr>
+          <a:lstStyle/>
+          <a:p>
+            <a:pPr>
+              <a:defRPr sz="2800" b="1"/>
+            </a:pPr>
+            <a:r>
+              <a:t>Closing</a:t>
+            </a:r>
+          </a:p>
+        </p:txBody>
+      </p:sp>
+      <p:sp>
+        <p:nvSpPr>
+          <p:cNvPr id="3" name="TextBox 2"/>
+          <p:cNvSpPr txBox="1"/>
+          <p:nvPr/>
+        </p:nvSpPr>
+        <p:spPr>
+          <a:xfrm>
+            <a:off x="822960" y="1645920"/>
+            <a:ext cx="10607040" cy="4389120"/>
+          </a:xfrm>
+          <a:prstGeom prst="rect">
+            <a:avLst/>
+          </a:prstGeom>
+          <a:noFill/>
+        </p:spPr>
+        <p:txBody>
+          <a:bodyPr wrap="none">
+            <a:spAutoFit/>
+          </a:bodyPr>
+          <a:lstStyle/>
+          <a:p>
+            <a:pPr>
+              <a:defRPr sz="2500"/>
             </a:pPr>
             <a:r>
               <a:t>DON’T JUST DETECT THE SCAM.</a:t>
@@ -3514,9 +3587,6 @@
           <a:lstStyle/>
           <a:p>
             <a:pPr>
-              <a:spcAft>
-                <a:spcPts val="800"/>
-              </a:spcAft>
               <a:defRPr sz="2200"/>
             </a:pPr>
             <a:r>
@@ -3597,9 +3667,6 @@
           <a:lstStyle/>
           <a:p>
             <a:pPr>
-              <a:spcAft>
-                <a:spcPts val="800"/>
-              </a:spcAft>
               <a:defRPr sz="2200"/>
             </a:pPr>
             <a:r>
@@ -3684,9 +3751,6 @@
           <a:lstStyle/>
           <a:p>
             <a:pPr>
-              <a:spcAft>
-                <a:spcPts val="800"/>
-              </a:spcAft>
               <a:defRPr sz="2200"/>
             </a:pPr>
             <a:r>
@@ -3767,9 +3831,6 @@
           <a:lstStyle/>
           <a:p>
             <a:pPr>
-              <a:spcAft>
-                <a:spcPts val="800"/>
-              </a:spcAft>
               <a:defRPr sz="2200"/>
             </a:pPr>
             <a:r>
@@ -3862,9 +3923,6 @@
           <a:lstStyle/>
           <a:p>
             <a:pPr>
-              <a:spcAft>
-                <a:spcPts val="800"/>
-              </a:spcAft>
               <a:defRPr sz="2200"/>
             </a:pPr>
             <a:r>
@@ -3949,9 +4007,6 @@
           <a:lstStyle/>
           <a:p>
             <a:pPr>
-              <a:spcAft>
-                <a:spcPts val="800"/>
-              </a:spcAft>
               <a:defRPr sz="2200"/>
             </a:pPr>
             <a:r>
@@ -4036,9 +4091,6 @@
           <a:lstStyle/>
           <a:p>
             <a:pPr>
-              <a:spcAft>
-                <a:spcPts val="800"/>
-              </a:spcAft>
               <a:defRPr sz="2200"/>
             </a:pPr>
             <a:r>
@@ -4123,9 +4175,6 @@
           <a:lstStyle/>
           <a:p>
             <a:pPr>
-              <a:spcAft>
-                <a:spcPts val="800"/>
-              </a:spcAft>
               <a:defRPr sz="2200"/>
             </a:pPr>
             <a:r>

</xml_diff>